<commit_message>
Balladen Woche 1: Paddy Fingal ohne Schnipsel (Lehrbuch + Heft), Gliedern/Nacherzählen statt John Maynard, Grobplanung angepasst
Co-Authored-By: Claude Opus 5.5 <noreply@anthropic.com>
Claude-Session: https://claude.ai/code/session_01KXvLXHMYPnCyEbMRgNaaYs
</commit_message>
<xml_diff>
--- a/Deutsch_7A/Balladen/Woche1/Praesentation_Paddy_Fingal_Lesetechniken.pptx
+++ b/Deutsch_7A/Balladen/Woche1/Praesentation_Paddy_Fingal_Lesetechniken.pptx
@@ -6418,7 +6418,7 @@
                 <a:ea typeface="Calibri" pitchFamily="34" charset="-122"/>
                 <a:cs typeface="Calibri" pitchFamily="34" charset="-120"/>
               </a:rPr>
-              <a:t>Klebe den Schnipsel Ü1 ins Heft. Schlage S. 136 f. auf.</a:t>
+              <a:t>Schreibe ins Heft: Ü1 Paddy Fingal lesen – a). Schlage S. 136 f. auf.</a:t>
             </a:r>
             <a:endParaRPr lang="en-US" sz="2100" dirty="0"/>
           </a:p>
@@ -7246,7 +7246,7 @@
                 <a:ea typeface="Calibri" pitchFamily="34" charset="-122"/>
                 <a:cs typeface="Calibri" pitchFamily="34" charset="-120"/>
               </a:rPr>
-              <a:t>Schreibe in Ü1: Die Ballade wirkt lustig / spannend / unheimlich, weil …</a:t>
+              <a:t>Schreibe ins Heft: Die Ballade wirkt lustig / spannend / unheimlich, weil …</a:t>
             </a:r>
             <a:endParaRPr lang="en-US" sz="2100" dirty="0"/>
           </a:p>
@@ -7766,7 +7766,7 @@
                 <a:ea typeface="Calibri" pitchFamily="34" charset="-122"/>
                 <a:cs typeface="Calibri" pitchFamily="34" charset="-120"/>
               </a:rPr>
-              <a:t>Notiere die Antwort und die Strophe auf dem Schnipsel.</a:t>
+              <a:t>Schreibe b) ins Heft. Notiere die Antwort und die Strophe.</a:t>
             </a:r>
             <a:endParaRPr lang="en-US" sz="2100" dirty="0"/>
           </a:p>
@@ -8406,7 +8406,7 @@
                 <a:ea typeface="Calibri" pitchFamily="34" charset="-122"/>
                 <a:cs typeface="Calibri" pitchFamily="34" charset="-120"/>
               </a:rPr>
-              <a:t>Lies Strophe 7 bis 9 Satz für Satz.</a:t>
+              <a:t>Schreibe c) ins Heft. Lies Strophe 7 bis 9 Satz für Satz.</a:t>
             </a:r>
             <a:endParaRPr lang="en-US" sz="2100" dirty="0"/>
           </a:p>

</xml_diff>